<commit_message>
Rebrand Day 1 deck text from BARE to Bridges & Allies (logo image pending file upload)
</commit_message>
<xml_diff>
--- a/bare-training/BARE_OffPlan_Training_Day1.pptx
+++ b/bare-training/BARE_OffPlan_Training_Day1.pptx
@@ -2996,7 +2996,7 @@
         <p:spPr>
           <a:xfrm>
             <a:off x="548640" y="2057400"/>
-            <a:ext cx="7315200" cy="457200"/>
+            <a:ext cx="8229600" cy="457200"/>
           </a:xfrm>
           <a:prstGeom prst="rect">
             <a:avLst/>
@@ -3012,7 +3012,7 @@
               <a:buNone/>
             </a:pPr>
             <a:r>
-              <a:rPr lang="en-US" sz="1800" b="1" spc="600" kern="0" dirty="0">
+              <a:rPr lang="en-US" sz="1600" b="1" spc="400" kern="0" dirty="0">
                 <a:solidFill>
                   <a:srgbClr val="C9A24B"/>
                 </a:solidFill>
@@ -3020,9 +3020,9 @@
                 <a:ea typeface="Cambria" pitchFamily="34" charset="-122"/>
                 <a:cs typeface="Cambria" pitchFamily="34" charset="-120"/>
               </a:rPr>
-              <a:t>BARE</a:t>
-            </a:r>
-            <a:endParaRPr lang="en-US" sz="1800" dirty="0"/>
+              <a:t>BRIDGES &amp; ALLIES</a:t>
+            </a:r>
+            <a:endParaRPr lang="en-US" sz="1600" dirty="0"/>
           </a:p>
         </p:txBody>
       </p:sp>
@@ -3176,7 +3176,7 @@
                 <a:ea typeface="Calibri" pitchFamily="34" charset="-122"/>
                 <a:cs typeface="Calibri" pitchFamily="34" charset="-120"/>
               </a:rPr>
-              <a:t>Presenter: ______________     ·     BARE — Off-Plan Team</a:t>
+              <a:t>Presenter: ______________     ·     Bridges &amp; Allies — Off-Plan Team</a:t>
             </a:r>
             <a:endParaRPr lang="en-US" sz="1200" dirty="0"/>
           </a:p>
@@ -3300,8 +3300,8 @@
         </p:nvSpPr>
         <p:spPr>
           <a:xfrm>
-            <a:off x="10637215" y="292608"/>
-            <a:ext cx="1097280" cy="365760"/>
+            <a:off x="9448495" y="310896"/>
+            <a:ext cx="2194560" cy="365760"/>
           </a:xfrm>
           <a:prstGeom prst="rect">
             <a:avLst/>
@@ -3317,7 +3317,7 @@
               <a:buNone/>
             </a:pPr>
             <a:r>
-              <a:rPr lang="en-US" sz="1400" b="1" spc="300" kern="0" dirty="0">
+              <a:rPr lang="en-US" sz="1100" b="1" spc="100" kern="0" dirty="0">
                 <a:solidFill>
                   <a:srgbClr val="C9A24B"/>
                 </a:solidFill>
@@ -3325,9 +3325,9 @@
                 <a:ea typeface="Cambria" pitchFamily="34" charset="-122"/>
                 <a:cs typeface="Cambria" pitchFamily="34" charset="-120"/>
               </a:rPr>
-              <a:t>BARE</a:t>
-            </a:r>
-            <a:endParaRPr lang="en-US" sz="1400" dirty="0"/>
+              <a:t>bridges &amp; allies</a:t>
+            </a:r>
+            <a:endParaRPr lang="en-US" sz="1100" dirty="0"/>
           </a:p>
         </p:txBody>
       </p:sp>
@@ -4232,8 +4232,8 @@
         </p:nvSpPr>
         <p:spPr>
           <a:xfrm>
-            <a:off x="10637215" y="292608"/>
-            <a:ext cx="1097280" cy="365760"/>
+            <a:off x="9448495" y="310896"/>
+            <a:ext cx="2194560" cy="365760"/>
           </a:xfrm>
           <a:prstGeom prst="rect">
             <a:avLst/>
@@ -4249,7 +4249,7 @@
               <a:buNone/>
             </a:pPr>
             <a:r>
-              <a:rPr lang="en-US" sz="1400" b="1" spc="300" kern="0" dirty="0">
+              <a:rPr lang="en-US" sz="1100" b="1" spc="100" kern="0" dirty="0">
                 <a:solidFill>
                   <a:srgbClr val="C9A24B"/>
                 </a:solidFill>
@@ -4257,9 +4257,9 @@
                 <a:ea typeface="Cambria" pitchFamily="34" charset="-122"/>
                 <a:cs typeface="Cambria" pitchFamily="34" charset="-120"/>
               </a:rPr>
-              <a:t>BARE</a:t>
-            </a:r>
-            <a:endParaRPr lang="en-US" sz="1400" dirty="0"/>
+              <a:t>bridges &amp; allies</a:t>
+            </a:r>
+            <a:endParaRPr lang="en-US" sz="1100" dirty="0"/>
           </a:p>
         </p:txBody>
       </p:sp>
@@ -4579,7 +4579,7 @@
                 <a:ea typeface="Calibri" pitchFamily="34" charset="-122"/>
                 <a:cs typeface="Calibri" pitchFamily="34" charset="-120"/>
               </a:rPr>
-              <a:t>As your licensed brokerage, BARE provides the sponsorship and visa pathway.</a:t>
+              <a:t>As your licensed brokerage, Bridges &amp; Allies provides the sponsorship and visa pathway.</a:t>
             </a:r>
             <a:endParaRPr lang="en-US" sz="1250" dirty="0"/>
           </a:p>
@@ -4825,8 +4825,8 @@
         </p:nvSpPr>
         <p:spPr>
           <a:xfrm>
-            <a:off x="10637215" y="292608"/>
-            <a:ext cx="1097280" cy="365760"/>
+            <a:off x="9448495" y="310896"/>
+            <a:ext cx="2194560" cy="365760"/>
           </a:xfrm>
           <a:prstGeom prst="rect">
             <a:avLst/>
@@ -4842,7 +4842,7 @@
               <a:buNone/>
             </a:pPr>
             <a:r>
-              <a:rPr lang="en-US" sz="1400" b="1" spc="300" kern="0" dirty="0">
+              <a:rPr lang="en-US" sz="1100" b="1" spc="100" kern="0" dirty="0">
                 <a:solidFill>
                   <a:srgbClr val="C9A24B"/>
                 </a:solidFill>
@@ -4850,9 +4850,9 @@
                 <a:ea typeface="Cambria" pitchFamily="34" charset="-122"/>
                 <a:cs typeface="Cambria" pitchFamily="34" charset="-120"/>
               </a:rPr>
-              <a:t>BARE</a:t>
-            </a:r>
-            <a:endParaRPr lang="en-US" sz="1400" dirty="0"/>
+              <a:t>bridges &amp; allies</a:t>
+            </a:r>
+            <a:endParaRPr lang="en-US" sz="1100" dirty="0"/>
           </a:p>
         </p:txBody>
       </p:sp>
@@ -5652,8 +5652,8 @@
         </p:nvSpPr>
         <p:spPr>
           <a:xfrm>
-            <a:off x="10637215" y="292608"/>
-            <a:ext cx="1097280" cy="365760"/>
+            <a:off x="9448495" y="310896"/>
+            <a:ext cx="2194560" cy="365760"/>
           </a:xfrm>
           <a:prstGeom prst="rect">
             <a:avLst/>
@@ -5669,7 +5669,7 @@
               <a:buNone/>
             </a:pPr>
             <a:r>
-              <a:rPr lang="en-US" sz="1400" b="1" spc="300" kern="0" dirty="0">
+              <a:rPr lang="en-US" sz="1100" b="1" spc="100" kern="0" dirty="0">
                 <a:solidFill>
                   <a:srgbClr val="C9A24B"/>
                 </a:solidFill>
@@ -5677,9 +5677,9 @@
                 <a:ea typeface="Cambria" pitchFamily="34" charset="-122"/>
                 <a:cs typeface="Cambria" pitchFamily="34" charset="-120"/>
               </a:rPr>
-              <a:t>BARE</a:t>
-            </a:r>
-            <a:endParaRPr lang="en-US" sz="1400" dirty="0"/>
+              <a:t>bridges &amp; allies</a:t>
+            </a:r>
+            <a:endParaRPr lang="en-US" sz="1100" dirty="0"/>
           </a:p>
         </p:txBody>
       </p:sp>
@@ -6516,8 +6516,8 @@
         </p:nvSpPr>
         <p:spPr>
           <a:xfrm>
-            <a:off x="10637215" y="292608"/>
-            <a:ext cx="1097280" cy="365760"/>
+            <a:off x="9448495" y="310896"/>
+            <a:ext cx="2194560" cy="365760"/>
           </a:xfrm>
           <a:prstGeom prst="rect">
             <a:avLst/>
@@ -6533,7 +6533,7 @@
               <a:buNone/>
             </a:pPr>
             <a:r>
-              <a:rPr lang="en-US" sz="1400" b="1" spc="300" kern="0" dirty="0">
+              <a:rPr lang="en-US" sz="1100" b="1" spc="100" kern="0" dirty="0">
                 <a:solidFill>
                   <a:srgbClr val="C9A24B"/>
                 </a:solidFill>
@@ -6541,9 +6541,9 @@
                 <a:ea typeface="Cambria" pitchFamily="34" charset="-122"/>
                 <a:cs typeface="Cambria" pitchFamily="34" charset="-120"/>
               </a:rPr>
-              <a:t>BARE</a:t>
-            </a:r>
-            <a:endParaRPr lang="en-US" sz="1400" dirty="0"/>
+              <a:t>bridges &amp; allies</a:t>
+            </a:r>
+            <a:endParaRPr lang="en-US" sz="1100" dirty="0"/>
           </a:p>
         </p:txBody>
       </p:sp>
@@ -7309,8 +7309,8 @@
         </p:nvSpPr>
         <p:spPr>
           <a:xfrm>
-            <a:off x="10637215" y="292608"/>
-            <a:ext cx="1097280" cy="365760"/>
+            <a:off x="9448495" y="310896"/>
+            <a:ext cx="2194560" cy="365760"/>
           </a:xfrm>
           <a:prstGeom prst="rect">
             <a:avLst/>
@@ -7326,7 +7326,7 @@
               <a:buNone/>
             </a:pPr>
             <a:r>
-              <a:rPr lang="en-US" sz="1400" b="1" spc="300" kern="0" dirty="0">
+              <a:rPr lang="en-US" sz="1100" b="1" spc="100" kern="0" dirty="0">
                 <a:solidFill>
                   <a:srgbClr val="C9A24B"/>
                 </a:solidFill>
@@ -7334,9 +7334,9 @@
                 <a:ea typeface="Cambria" pitchFamily="34" charset="-122"/>
                 <a:cs typeface="Cambria" pitchFamily="34" charset="-120"/>
               </a:rPr>
-              <a:t>BARE</a:t>
-            </a:r>
-            <a:endParaRPr lang="en-US" sz="1400" dirty="0"/>
+              <a:t>bridges &amp; allies</a:t>
+            </a:r>
+            <a:endParaRPr lang="en-US" sz="1100" dirty="0"/>
           </a:p>
         </p:txBody>
       </p:sp>
@@ -8385,8 +8385,8 @@
         </p:nvSpPr>
         <p:spPr>
           <a:xfrm>
-            <a:off x="10637215" y="292608"/>
-            <a:ext cx="1097280" cy="365760"/>
+            <a:off x="9448495" y="310896"/>
+            <a:ext cx="2194560" cy="365760"/>
           </a:xfrm>
           <a:prstGeom prst="rect">
             <a:avLst/>
@@ -8402,7 +8402,7 @@
               <a:buNone/>
             </a:pPr>
             <a:r>
-              <a:rPr lang="en-US" sz="1400" b="1" spc="300" kern="0" dirty="0">
+              <a:rPr lang="en-US" sz="1100" b="1" spc="100" kern="0" dirty="0">
                 <a:solidFill>
                   <a:srgbClr val="C9A24B"/>
                 </a:solidFill>
@@ -8410,9 +8410,9 @@
                 <a:ea typeface="Cambria" pitchFamily="34" charset="-122"/>
                 <a:cs typeface="Cambria" pitchFamily="34" charset="-120"/>
               </a:rPr>
-              <a:t>BARE</a:t>
-            </a:r>
-            <a:endParaRPr lang="en-US" sz="1400" dirty="0"/>
+              <a:t>bridges &amp; allies</a:t>
+            </a:r>
+            <a:endParaRPr lang="en-US" sz="1100" dirty="0"/>
           </a:p>
         </p:txBody>
       </p:sp>
@@ -9565,8 +9565,8 @@
         </p:nvSpPr>
         <p:spPr>
           <a:xfrm>
-            <a:off x="10637215" y="292608"/>
-            <a:ext cx="1097280" cy="365760"/>
+            <a:off x="9448495" y="310896"/>
+            <a:ext cx="2194560" cy="365760"/>
           </a:xfrm>
           <a:prstGeom prst="rect">
             <a:avLst/>
@@ -9582,7 +9582,7 @@
               <a:buNone/>
             </a:pPr>
             <a:r>
-              <a:rPr lang="en-US" sz="1400" b="1" spc="300" kern="0" dirty="0">
+              <a:rPr lang="en-US" sz="1100" b="1" spc="100" kern="0" dirty="0">
                 <a:solidFill>
                   <a:srgbClr val="C9A24B"/>
                 </a:solidFill>
@@ -9590,9 +9590,9 @@
                 <a:ea typeface="Cambria" pitchFamily="34" charset="-122"/>
                 <a:cs typeface="Cambria" pitchFamily="34" charset="-120"/>
               </a:rPr>
-              <a:t>BARE</a:t>
-            </a:r>
-            <a:endParaRPr lang="en-US" sz="1400" dirty="0"/>
+              <a:t>bridges &amp; allies</a:t>
+            </a:r>
+            <a:endParaRPr lang="en-US" sz="1100" dirty="0"/>
           </a:p>
         </p:txBody>
       </p:sp>
@@ -10784,8 +10784,8 @@
         </p:nvSpPr>
         <p:spPr>
           <a:xfrm>
-            <a:off x="10637215" y="292608"/>
-            <a:ext cx="1097280" cy="365760"/>
+            <a:off x="9448495" y="310896"/>
+            <a:ext cx="2194560" cy="365760"/>
           </a:xfrm>
           <a:prstGeom prst="rect">
             <a:avLst/>
@@ -10801,7 +10801,7 @@
               <a:buNone/>
             </a:pPr>
             <a:r>
-              <a:rPr lang="en-US" sz="1400" b="1" spc="300" kern="0" dirty="0">
+              <a:rPr lang="en-US" sz="1100" b="1" spc="100" kern="0" dirty="0">
                 <a:solidFill>
                   <a:srgbClr val="C9A24B"/>
                 </a:solidFill>
@@ -10809,9 +10809,9 @@
                 <a:ea typeface="Cambria" pitchFamily="34" charset="-122"/>
                 <a:cs typeface="Cambria" pitchFamily="34" charset="-120"/>
               </a:rPr>
-              <a:t>BARE</a:t>
-            </a:r>
-            <a:endParaRPr lang="en-US" sz="1400" dirty="0"/>
+              <a:t>bridges &amp; allies</a:t>
+            </a:r>
+            <a:endParaRPr lang="en-US" sz="1100" dirty="0"/>
           </a:p>
         </p:txBody>
       </p:sp>
@@ -11699,8 +11699,8 @@
         </p:nvSpPr>
         <p:spPr>
           <a:xfrm>
-            <a:off x="10637215" y="292608"/>
-            <a:ext cx="1097280" cy="365760"/>
+            <a:off x="9448495" y="310896"/>
+            <a:ext cx="2194560" cy="365760"/>
           </a:xfrm>
           <a:prstGeom prst="rect">
             <a:avLst/>
@@ -11716,7 +11716,7 @@
               <a:buNone/>
             </a:pPr>
             <a:r>
-              <a:rPr lang="en-US" sz="1400" b="1" spc="300" kern="0" dirty="0">
+              <a:rPr lang="en-US" sz="1100" b="1" spc="100" kern="0" dirty="0">
                 <a:solidFill>
                   <a:srgbClr val="C9A24B"/>
                 </a:solidFill>
@@ -11724,9 +11724,9 @@
                 <a:ea typeface="Cambria" pitchFamily="34" charset="-122"/>
                 <a:cs typeface="Cambria" pitchFamily="34" charset="-120"/>
               </a:rPr>
-              <a:t>BARE</a:t>
-            </a:r>
-            <a:endParaRPr lang="en-US" sz="1400" dirty="0"/>
+              <a:t>bridges &amp; allies</a:t>
+            </a:r>
+            <a:endParaRPr lang="en-US" sz="1100" dirty="0"/>
           </a:p>
         </p:txBody>
       </p:sp>
@@ -12479,8 +12479,8 @@
         </p:nvSpPr>
         <p:spPr>
           <a:xfrm>
-            <a:off x="10637215" y="292608"/>
-            <a:ext cx="1097280" cy="365760"/>
+            <a:off x="9448495" y="310896"/>
+            <a:ext cx="2194560" cy="365760"/>
           </a:xfrm>
           <a:prstGeom prst="rect">
             <a:avLst/>
@@ -12496,7 +12496,7 @@
               <a:buNone/>
             </a:pPr>
             <a:r>
-              <a:rPr lang="en-US" sz="1400" b="1" spc="300" kern="0" dirty="0">
+              <a:rPr lang="en-US" sz="1100" b="1" spc="100" kern="0" dirty="0">
                 <a:solidFill>
                   <a:srgbClr val="C9A24B"/>
                 </a:solidFill>
@@ -12504,9 +12504,9 @@
                 <a:ea typeface="Cambria" pitchFamily="34" charset="-122"/>
                 <a:cs typeface="Cambria" pitchFamily="34" charset="-120"/>
               </a:rPr>
-              <a:t>BARE</a:t>
-            </a:r>
-            <a:endParaRPr lang="en-US" sz="1400" dirty="0"/>
+              <a:t>bridges &amp; allies</a:t>
+            </a:r>
+            <a:endParaRPr lang="en-US" sz="1100" dirty="0"/>
           </a:p>
         </p:txBody>
       </p:sp>
@@ -13820,8 +13820,8 @@
         </p:nvSpPr>
         <p:spPr>
           <a:xfrm>
-            <a:off x="10637215" y="292608"/>
-            <a:ext cx="1097280" cy="365760"/>
+            <a:off x="9448495" y="310896"/>
+            <a:ext cx="2194560" cy="365760"/>
           </a:xfrm>
           <a:prstGeom prst="rect">
             <a:avLst/>
@@ -13837,7 +13837,7 @@
               <a:buNone/>
             </a:pPr>
             <a:r>
-              <a:rPr lang="en-US" sz="1400" b="1" spc="300" kern="0" dirty="0">
+              <a:rPr lang="en-US" sz="1100" b="1" spc="100" kern="0" dirty="0">
                 <a:solidFill>
                   <a:srgbClr val="C9A24B"/>
                 </a:solidFill>
@@ -13845,9 +13845,9 @@
                 <a:ea typeface="Cambria" pitchFamily="34" charset="-122"/>
                 <a:cs typeface="Cambria" pitchFamily="34" charset="-120"/>
               </a:rPr>
-              <a:t>BARE</a:t>
-            </a:r>
-            <a:endParaRPr lang="en-US" sz="1400" dirty="0"/>
+              <a:t>bridges &amp; allies</a:t>
+            </a:r>
+            <a:endParaRPr lang="en-US" sz="1100" dirty="0"/>
           </a:p>
         </p:txBody>
       </p:sp>
@@ -13930,8 +13930,8 @@
         </p:nvSpPr>
         <p:spPr>
           <a:xfrm>
-            <a:off x="10637215" y="292608"/>
-            <a:ext cx="1097280" cy="365760"/>
+            <a:off x="9448495" y="310896"/>
+            <a:ext cx="2194560" cy="365760"/>
           </a:xfrm>
           <a:prstGeom prst="rect">
             <a:avLst/>
@@ -13947,7 +13947,7 @@
               <a:buNone/>
             </a:pPr>
             <a:r>
-              <a:rPr lang="en-US" sz="1400" b="1" spc="300" kern="0" dirty="0">
+              <a:rPr lang="en-US" sz="1100" b="1" spc="100" kern="0" dirty="0">
                 <a:solidFill>
                   <a:srgbClr val="C9A24B"/>
                 </a:solidFill>
@@ -13955,9 +13955,9 @@
                 <a:ea typeface="Cambria" pitchFamily="34" charset="-122"/>
                 <a:cs typeface="Cambria" pitchFamily="34" charset="-120"/>
               </a:rPr>
-              <a:t>BARE</a:t>
-            </a:r>
-            <a:endParaRPr lang="en-US" sz="1400" dirty="0"/>
+              <a:t>bridges &amp; allies</a:t>
+            </a:r>
+            <a:endParaRPr lang="en-US" sz="1100" dirty="0"/>
           </a:p>
         </p:txBody>
       </p:sp>
@@ -14724,8 +14724,8 @@
         </p:nvSpPr>
         <p:spPr>
           <a:xfrm>
-            <a:off x="10637215" y="292608"/>
-            <a:ext cx="1097280" cy="365760"/>
+            <a:off x="9448495" y="310896"/>
+            <a:ext cx="2194560" cy="365760"/>
           </a:xfrm>
           <a:prstGeom prst="rect">
             <a:avLst/>
@@ -14741,7 +14741,7 @@
               <a:buNone/>
             </a:pPr>
             <a:r>
-              <a:rPr lang="en-US" sz="1400" b="1" spc="300" kern="0" dirty="0">
+              <a:rPr lang="en-US" sz="1100" b="1" spc="100" kern="0" dirty="0">
                 <a:solidFill>
                   <a:srgbClr val="C9A24B"/>
                 </a:solidFill>
@@ -14749,9 +14749,9 @@
                 <a:ea typeface="Cambria" pitchFamily="34" charset="-122"/>
                 <a:cs typeface="Cambria" pitchFamily="34" charset="-120"/>
               </a:rPr>
-              <a:t>BARE</a:t>
-            </a:r>
-            <a:endParaRPr lang="en-US" sz="1400" dirty="0"/>
+              <a:t>bridges &amp; allies</a:t>
+            </a:r>
+            <a:endParaRPr lang="en-US" sz="1100" dirty="0"/>
           </a:p>
         </p:txBody>
       </p:sp>
@@ -15845,8 +15845,8 @@
         </p:nvSpPr>
         <p:spPr>
           <a:xfrm>
-            <a:off x="10637215" y="292608"/>
-            <a:ext cx="1097280" cy="365760"/>
+            <a:off x="9448495" y="310896"/>
+            <a:ext cx="2194560" cy="365760"/>
           </a:xfrm>
           <a:prstGeom prst="rect">
             <a:avLst/>
@@ -15862,7 +15862,7 @@
               <a:buNone/>
             </a:pPr>
             <a:r>
-              <a:rPr lang="en-US" sz="1400" b="1" spc="300" kern="0" dirty="0">
+              <a:rPr lang="en-US" sz="1100" b="1" spc="100" kern="0" dirty="0">
                 <a:solidFill>
                   <a:srgbClr val="C9A24B"/>
                 </a:solidFill>
@@ -15870,9 +15870,9 @@
                 <a:ea typeface="Cambria" pitchFamily="34" charset="-122"/>
                 <a:cs typeface="Cambria" pitchFamily="34" charset="-120"/>
               </a:rPr>
-              <a:t>BARE</a:t>
-            </a:r>
-            <a:endParaRPr lang="en-US" sz="1400" dirty="0"/>
+              <a:t>bridges &amp; allies</a:t>
+            </a:r>
+            <a:endParaRPr lang="en-US" sz="1100" dirty="0"/>
           </a:p>
         </p:txBody>
       </p:sp>
@@ -15955,8 +15955,8 @@
         </p:nvSpPr>
         <p:spPr>
           <a:xfrm>
-            <a:off x="10637215" y="292608"/>
-            <a:ext cx="1097280" cy="365760"/>
+            <a:off x="9448495" y="310896"/>
+            <a:ext cx="2194560" cy="365760"/>
           </a:xfrm>
           <a:prstGeom prst="rect">
             <a:avLst/>
@@ -15972,7 +15972,7 @@
               <a:buNone/>
             </a:pPr>
             <a:r>
-              <a:rPr lang="en-US" sz="1400" b="1" spc="300" kern="0" dirty="0">
+              <a:rPr lang="en-US" sz="1100" b="1" spc="100" kern="0" dirty="0">
                 <a:solidFill>
                   <a:srgbClr val="C9A24B"/>
                 </a:solidFill>
@@ -15980,9 +15980,9 @@
                 <a:ea typeface="Cambria" pitchFamily="34" charset="-122"/>
                 <a:cs typeface="Cambria" pitchFamily="34" charset="-120"/>
               </a:rPr>
-              <a:t>BARE</a:t>
-            </a:r>
-            <a:endParaRPr lang="en-US" sz="1400" dirty="0"/>
+              <a:t>bridges &amp; allies</a:t>
+            </a:r>
+            <a:endParaRPr lang="en-US" sz="1100" dirty="0"/>
           </a:p>
         </p:txBody>
       </p:sp>
@@ -17056,8 +17056,8 @@
         </p:nvSpPr>
         <p:spPr>
           <a:xfrm>
-            <a:off x="10637215" y="292608"/>
-            <a:ext cx="1097280" cy="365760"/>
+            <a:off x="9448495" y="310896"/>
+            <a:ext cx="2194560" cy="365760"/>
           </a:xfrm>
           <a:prstGeom prst="rect">
             <a:avLst/>
@@ -17073,7 +17073,7 @@
               <a:buNone/>
             </a:pPr>
             <a:r>
-              <a:rPr lang="en-US" sz="1400" b="1" spc="300" kern="0" dirty="0">
+              <a:rPr lang="en-US" sz="1100" b="1" spc="100" kern="0" dirty="0">
                 <a:solidFill>
                   <a:srgbClr val="C9A24B"/>
                 </a:solidFill>
@@ -17081,9 +17081,9 @@
                 <a:ea typeface="Cambria" pitchFamily="34" charset="-122"/>
                 <a:cs typeface="Cambria" pitchFamily="34" charset="-120"/>
               </a:rPr>
-              <a:t>BARE</a:t>
-            </a:r>
-            <a:endParaRPr lang="en-US" sz="1400" dirty="0"/>
+              <a:t>bridges &amp; allies</a:t>
+            </a:r>
+            <a:endParaRPr lang="en-US" sz="1100" dirty="0"/>
           </a:p>
         </p:txBody>
       </p:sp>
@@ -17734,8 +17734,8 @@
         </p:nvSpPr>
         <p:spPr>
           <a:xfrm>
-            <a:off x="10637215" y="292608"/>
-            <a:ext cx="1097280" cy="365760"/>
+            <a:off x="9448495" y="310896"/>
+            <a:ext cx="2194560" cy="365760"/>
           </a:xfrm>
           <a:prstGeom prst="rect">
             <a:avLst/>
@@ -17751,7 +17751,7 @@
               <a:buNone/>
             </a:pPr>
             <a:r>
-              <a:rPr lang="en-US" sz="1400" b="1" spc="300" kern="0" dirty="0">
+              <a:rPr lang="en-US" sz="1100" b="1" spc="100" kern="0" dirty="0">
                 <a:solidFill>
                   <a:srgbClr val="C9A24B"/>
                 </a:solidFill>
@@ -17759,9 +17759,9 @@
                 <a:ea typeface="Cambria" pitchFamily="34" charset="-122"/>
                 <a:cs typeface="Cambria" pitchFamily="34" charset="-120"/>
               </a:rPr>
-              <a:t>BARE</a:t>
-            </a:r>
-            <a:endParaRPr lang="en-US" sz="1400" dirty="0"/>
+              <a:t>bridges &amp; allies</a:t>
+            </a:r>
+            <a:endParaRPr lang="en-US" sz="1100" dirty="0"/>
           </a:p>
         </p:txBody>
       </p:sp>
@@ -18527,8 +18527,8 @@
         </p:nvSpPr>
         <p:spPr>
           <a:xfrm>
-            <a:off x="10637215" y="292608"/>
-            <a:ext cx="1097280" cy="365760"/>
+            <a:off x="9448495" y="310896"/>
+            <a:ext cx="2194560" cy="365760"/>
           </a:xfrm>
           <a:prstGeom prst="rect">
             <a:avLst/>
@@ -18544,7 +18544,7 @@
               <a:buNone/>
             </a:pPr>
             <a:r>
-              <a:rPr lang="en-US" sz="1400" b="1" spc="300" kern="0" dirty="0">
+              <a:rPr lang="en-US" sz="1100" b="1" spc="100" kern="0" dirty="0">
                 <a:solidFill>
                   <a:srgbClr val="C9A24B"/>
                 </a:solidFill>
@@ -18552,9 +18552,9 @@
                 <a:ea typeface="Cambria" pitchFamily="34" charset="-122"/>
                 <a:cs typeface="Cambria" pitchFamily="34" charset="-120"/>
               </a:rPr>
-              <a:t>BARE</a:t>
-            </a:r>
-            <a:endParaRPr lang="en-US" sz="1400" dirty="0"/>
+              <a:t>bridges &amp; allies</a:t>
+            </a:r>
+            <a:endParaRPr lang="en-US" sz="1100" dirty="0"/>
           </a:p>
         </p:txBody>
       </p:sp>
@@ -19332,8 +19332,8 @@
         </p:nvSpPr>
         <p:spPr>
           <a:xfrm>
-            <a:off x="10637215" y="292608"/>
-            <a:ext cx="1097280" cy="365760"/>
+            <a:off x="9448495" y="310896"/>
+            <a:ext cx="2194560" cy="365760"/>
           </a:xfrm>
           <a:prstGeom prst="rect">
             <a:avLst/>
@@ -19349,7 +19349,7 @@
               <a:buNone/>
             </a:pPr>
             <a:r>
-              <a:rPr lang="en-US" sz="1400" b="1" spc="300" kern="0" dirty="0">
+              <a:rPr lang="en-US" sz="1100" b="1" spc="100" kern="0" dirty="0">
                 <a:solidFill>
                   <a:srgbClr val="C9A24B"/>
                 </a:solidFill>
@@ -19357,9 +19357,9 @@
                 <a:ea typeface="Cambria" pitchFamily="34" charset="-122"/>
                 <a:cs typeface="Cambria" pitchFamily="34" charset="-120"/>
               </a:rPr>
-              <a:t>BARE</a:t>
-            </a:r>
-            <a:endParaRPr lang="en-US" sz="1400" dirty="0"/>
+              <a:t>bridges &amp; allies</a:t>
+            </a:r>
+            <a:endParaRPr lang="en-US" sz="1100" dirty="0"/>
           </a:p>
         </p:txBody>
       </p:sp>

</xml_diff>